<commit_message>
Update project and tests submodule reference
</commit_message>
<xml_diff>
--- a/architecture.pptx
+++ b/architecture.pptx
@@ -443,7 +443,7 @@
           <a:p>
             <a:fld id="{23DD2594-58B2-49B4-9943-5F45C727DCD2}" type="datetimeFigureOut">
               <a:rPr kumimoji="1" lang="ja-JP" altLang="en-US" smtClean="0"/>
-              <a:t>2026/6/6</a:t>
+              <a:t>2026/6/7</a:t>
             </a:fld>
             <a:endParaRPr kumimoji="1" lang="ja-JP" altLang="en-US"/>
           </a:p>
@@ -673,7 +673,7 @@
           <a:p>
             <a:fld id="{23DD2594-58B2-49B4-9943-5F45C727DCD2}" type="datetimeFigureOut">
               <a:rPr kumimoji="1" lang="ja-JP" altLang="en-US" smtClean="0"/>
-              <a:t>2026/6/6</a:t>
+              <a:t>2026/6/7</a:t>
             </a:fld>
             <a:endParaRPr kumimoji="1" lang="ja-JP" altLang="en-US"/>
           </a:p>
@@ -913,7 +913,7 @@
           <a:p>
             <a:fld id="{23DD2594-58B2-49B4-9943-5F45C727DCD2}" type="datetimeFigureOut">
               <a:rPr kumimoji="1" lang="ja-JP" altLang="en-US" smtClean="0"/>
-              <a:t>2026/6/6</a:t>
+              <a:t>2026/6/7</a:t>
             </a:fld>
             <a:endParaRPr kumimoji="1" lang="ja-JP" altLang="en-US"/>
           </a:p>
@@ -1143,7 +1143,7 @@
           <a:p>
             <a:fld id="{23DD2594-58B2-49B4-9943-5F45C727DCD2}" type="datetimeFigureOut">
               <a:rPr kumimoji="1" lang="ja-JP" altLang="en-US" smtClean="0"/>
-              <a:t>2026/6/6</a:t>
+              <a:t>2026/6/7</a:t>
             </a:fld>
             <a:endParaRPr kumimoji="1" lang="ja-JP" altLang="en-US"/>
           </a:p>
@@ -1418,7 +1418,7 @@
           <a:p>
             <a:fld id="{23DD2594-58B2-49B4-9943-5F45C727DCD2}" type="datetimeFigureOut">
               <a:rPr kumimoji="1" lang="ja-JP" altLang="en-US" smtClean="0"/>
-              <a:t>2026/6/6</a:t>
+              <a:t>2026/6/7</a:t>
             </a:fld>
             <a:endParaRPr kumimoji="1" lang="ja-JP" altLang="en-US"/>
           </a:p>
@@ -1747,7 +1747,7 @@
           <a:p>
             <a:fld id="{23DD2594-58B2-49B4-9943-5F45C727DCD2}" type="datetimeFigureOut">
               <a:rPr kumimoji="1" lang="ja-JP" altLang="en-US" smtClean="0"/>
-              <a:t>2026/6/6</a:t>
+              <a:t>2026/6/7</a:t>
             </a:fld>
             <a:endParaRPr kumimoji="1" lang="ja-JP" altLang="en-US"/>
           </a:p>
@@ -2223,7 +2223,7 @@
           <a:p>
             <a:fld id="{23DD2594-58B2-49B4-9943-5F45C727DCD2}" type="datetimeFigureOut">
               <a:rPr kumimoji="1" lang="ja-JP" altLang="en-US" smtClean="0"/>
-              <a:t>2026/6/6</a:t>
+              <a:t>2026/6/7</a:t>
             </a:fld>
             <a:endParaRPr kumimoji="1" lang="ja-JP" altLang="en-US"/>
           </a:p>
@@ -2364,7 +2364,7 @@
           <a:p>
             <a:fld id="{23DD2594-58B2-49B4-9943-5F45C727DCD2}" type="datetimeFigureOut">
               <a:rPr kumimoji="1" lang="ja-JP" altLang="en-US" smtClean="0"/>
-              <a:t>2026/6/6</a:t>
+              <a:t>2026/6/7</a:t>
             </a:fld>
             <a:endParaRPr kumimoji="1" lang="ja-JP" altLang="en-US"/>
           </a:p>
@@ -2477,7 +2477,7 @@
           <a:p>
             <a:fld id="{23DD2594-58B2-49B4-9943-5F45C727DCD2}" type="datetimeFigureOut">
               <a:rPr kumimoji="1" lang="ja-JP" altLang="en-US" smtClean="0"/>
-              <a:t>2026/6/6</a:t>
+              <a:t>2026/6/7</a:t>
             </a:fld>
             <a:endParaRPr kumimoji="1" lang="ja-JP" altLang="en-US"/>
           </a:p>
@@ -2820,7 +2820,7 @@
           <a:p>
             <a:fld id="{23DD2594-58B2-49B4-9943-5F45C727DCD2}" type="datetimeFigureOut">
               <a:rPr kumimoji="1" lang="ja-JP" altLang="en-US" smtClean="0"/>
-              <a:t>2026/6/6</a:t>
+              <a:t>2026/6/7</a:t>
             </a:fld>
             <a:endParaRPr kumimoji="1" lang="ja-JP" altLang="en-US"/>
           </a:p>
@@ -3108,7 +3108,7 @@
           <a:p>
             <a:fld id="{23DD2594-58B2-49B4-9943-5F45C727DCD2}" type="datetimeFigureOut">
               <a:rPr kumimoji="1" lang="ja-JP" altLang="en-US" smtClean="0"/>
-              <a:t>2026/6/6</a:t>
+              <a:t>2026/6/7</a:t>
             </a:fld>
             <a:endParaRPr kumimoji="1" lang="ja-JP" altLang="en-US"/>
           </a:p>
@@ -3381,7 +3381,7 @@
           <a:p>
             <a:fld id="{23DD2594-58B2-49B4-9943-5F45C727DCD2}" type="datetimeFigureOut">
               <a:rPr kumimoji="1" lang="ja-JP" altLang="en-US" smtClean="0"/>
-              <a:t>2026/6/6</a:t>
+              <a:t>2026/6/7</a:t>
             </a:fld>
             <a:endParaRPr kumimoji="1" lang="ja-JP" altLang="en-US"/>
           </a:p>
@@ -3812,7 +3812,7 @@
         </p:nvSpPr>
         <p:spPr>
           <a:xfrm>
-            <a:off x="1131435" y="3722791"/>
+            <a:off x="787059" y="3722791"/>
             <a:ext cx="1440000" cy="2138082"/>
           </a:xfrm>
           <a:prstGeom prst="rect">
@@ -3862,7 +3862,7 @@
         </p:nvSpPr>
         <p:spPr>
           <a:xfrm>
-            <a:off x="3615837" y="3722791"/>
+            <a:off x="3271461" y="3722791"/>
             <a:ext cx="1440000" cy="2160000"/>
           </a:xfrm>
           <a:prstGeom prst="rect">
@@ -3919,7 +3919,7 @@
         </p:nvSpPr>
         <p:spPr>
           <a:xfrm>
-            <a:off x="6100239" y="3722791"/>
+            <a:off x="5755863" y="3722791"/>
             <a:ext cx="1440000" cy="2138082"/>
           </a:xfrm>
           <a:prstGeom prst="rect">
@@ -3969,7 +3969,7 @@
         </p:nvSpPr>
         <p:spPr>
           <a:xfrm>
-            <a:off x="8584641" y="3722791"/>
+            <a:off x="8240265" y="3722791"/>
             <a:ext cx="1440000" cy="2138082"/>
           </a:xfrm>
           <a:prstGeom prst="rect">
@@ -4030,7 +4030,7 @@
         </p:nvCxnSpPr>
         <p:spPr>
           <a:xfrm>
-            <a:off x="2571435" y="4791832"/>
+            <a:off x="2227059" y="4791832"/>
             <a:ext cx="1044402" cy="10959"/>
           </a:xfrm>
           <a:prstGeom prst="straightConnector1">
@@ -4073,7 +4073,7 @@
         </p:nvCxnSpPr>
         <p:spPr>
           <a:xfrm flipV="1">
-            <a:off x="5055837" y="4791832"/>
+            <a:off x="4711461" y="4791832"/>
             <a:ext cx="1044402" cy="10959"/>
           </a:xfrm>
           <a:prstGeom prst="straightConnector1">
@@ -4115,7 +4115,7 @@
         </p:nvCxnSpPr>
         <p:spPr>
           <a:xfrm>
-            <a:off x="7540239" y="4791832"/>
+            <a:off x="7195863" y="4791832"/>
             <a:ext cx="1044402" cy="10959"/>
           </a:xfrm>
           <a:prstGeom prst="straightConnector1">
@@ -4158,7 +4158,7 @@
         </p:nvCxnSpPr>
         <p:spPr>
           <a:xfrm rot="5400000" flipH="1">
-            <a:off x="3082677" y="4629631"/>
+            <a:off x="2738301" y="4629631"/>
             <a:ext cx="21918" cy="2484402"/>
           </a:xfrm>
           <a:prstGeom prst="bentConnector3">
@@ -4203,7 +4203,7 @@
         </p:nvCxnSpPr>
         <p:spPr>
           <a:xfrm rot="5400000">
-            <a:off x="4335837" y="3376471"/>
+            <a:off x="3991461" y="3376471"/>
             <a:ext cx="12700" cy="4968804"/>
           </a:xfrm>
           <a:prstGeom prst="bentConnector3">
@@ -4248,7 +4248,7 @@
         </p:nvCxnSpPr>
         <p:spPr>
           <a:xfrm rot="5400000">
-            <a:off x="5578038" y="2134270"/>
+            <a:off x="5233662" y="2134270"/>
             <a:ext cx="12700" cy="7453206"/>
           </a:xfrm>
           <a:prstGeom prst="bentConnector3">
@@ -4289,7 +4289,7 @@
         </p:nvSpPr>
         <p:spPr>
           <a:xfrm>
-            <a:off x="2672506" y="4412354"/>
+            <a:off x="2328130" y="4412354"/>
             <a:ext cx="821072" cy="369332"/>
           </a:xfrm>
           <a:prstGeom prst="rect">
@@ -4325,7 +4325,7 @@
         </p:nvSpPr>
         <p:spPr>
           <a:xfrm>
-            <a:off x="5022103" y="5495793"/>
+            <a:off x="4677727" y="5495793"/>
             <a:ext cx="967634" cy="369332"/>
           </a:xfrm>
           <a:prstGeom prst="rect">
@@ -4361,7 +4361,7 @@
         </p:nvSpPr>
         <p:spPr>
           <a:xfrm>
-            <a:off x="711302" y="3270190"/>
+            <a:off x="366926" y="3270190"/>
             <a:ext cx="9629263" cy="3338425"/>
           </a:xfrm>
           <a:prstGeom prst="rect">
@@ -4408,7 +4408,7 @@
         </p:nvSpPr>
         <p:spPr>
           <a:xfrm>
-            <a:off x="5066589" y="3856811"/>
+            <a:off x="4722213" y="3856811"/>
             <a:ext cx="987999" cy="923330"/>
           </a:xfrm>
           <a:prstGeom prst="rect">
@@ -4444,7 +4444,7 @@
         </p:nvSpPr>
         <p:spPr>
           <a:xfrm>
-            <a:off x="7567777" y="3889860"/>
+            <a:off x="7223401" y="3889860"/>
             <a:ext cx="987999" cy="646331"/>
           </a:xfrm>
           <a:prstGeom prst="rect">
@@ -4483,7 +4483,7 @@
         </p:nvCxnSpPr>
         <p:spPr>
           <a:xfrm flipV="1">
-            <a:off x="6820239" y="2880000"/>
+            <a:off x="6475863" y="2880000"/>
             <a:ext cx="0" cy="842791"/>
           </a:xfrm>
           <a:prstGeom prst="straightConnector1">
@@ -4524,7 +4524,7 @@
         </p:nvCxnSpPr>
         <p:spPr>
           <a:xfrm flipV="1">
-            <a:off x="3972070" y="2872435"/>
+            <a:off x="3627694" y="2872435"/>
             <a:ext cx="0" cy="850356"/>
           </a:xfrm>
           <a:prstGeom prst="straightConnector1">
@@ -4563,7 +4563,7 @@
         </p:nvSpPr>
         <p:spPr>
           <a:xfrm>
-            <a:off x="2963258" y="2915025"/>
+            <a:off x="2618882" y="2915025"/>
             <a:ext cx="1008808" cy="646331"/>
           </a:xfrm>
           <a:prstGeom prst="rect">
@@ -4606,7 +4606,7 @@
         </p:nvCxnSpPr>
         <p:spPr>
           <a:xfrm>
-            <a:off x="4690917" y="2870691"/>
+            <a:off x="4346541" y="2870691"/>
             <a:ext cx="0" cy="852100"/>
           </a:xfrm>
           <a:prstGeom prst="straightConnector1">
@@ -4645,7 +4645,7 @@
         </p:nvSpPr>
         <p:spPr>
           <a:xfrm>
-            <a:off x="4704491" y="2919202"/>
+            <a:off x="4360115" y="2919202"/>
             <a:ext cx="973768" cy="646331"/>
           </a:xfrm>
           <a:prstGeom prst="rect">
@@ -4686,7 +4686,7 @@
         </p:nvSpPr>
         <p:spPr>
           <a:xfrm>
-            <a:off x="6825381" y="2807778"/>
+            <a:off x="6481005" y="2807778"/>
             <a:ext cx="971018" cy="923330"/>
           </a:xfrm>
           <a:prstGeom prst="rect">
@@ -4736,7 +4736,7 @@
         </p:nvCxnSpPr>
         <p:spPr>
           <a:xfrm>
-            <a:off x="9304641" y="2880000"/>
+            <a:off x="8960265" y="2880000"/>
             <a:ext cx="0" cy="842791"/>
           </a:xfrm>
           <a:prstGeom prst="straightConnector1">
@@ -4775,7 +4775,7 @@
         </p:nvSpPr>
         <p:spPr>
           <a:xfrm>
-            <a:off x="8207640" y="2816921"/>
+            <a:off x="7863264" y="2816921"/>
             <a:ext cx="1040575" cy="923330"/>
           </a:xfrm>
           <a:prstGeom prst="rect">
@@ -4826,7 +4826,7 @@
         </p:nvCxnSpPr>
         <p:spPr>
           <a:xfrm flipH="1">
-            <a:off x="1131435" y="4791832"/>
+            <a:off x="787059" y="4791832"/>
             <a:ext cx="8893206" cy="12700"/>
           </a:xfrm>
           <a:prstGeom prst="bentConnector5">
@@ -4869,7 +4869,7 @@
         </p:nvSpPr>
         <p:spPr>
           <a:xfrm>
-            <a:off x="3136380" y="6240807"/>
+            <a:off x="2792004" y="6240807"/>
             <a:ext cx="4683781" cy="369332"/>
           </a:xfrm>
           <a:prstGeom prst="rect">
@@ -4913,7 +4913,7 @@
         </p:nvSpPr>
         <p:spPr>
           <a:xfrm>
-            <a:off x="711303" y="249382"/>
+            <a:off x="366927" y="249382"/>
             <a:ext cx="9633846" cy="2945485"/>
           </a:xfrm>
           <a:prstGeom prst="rect">
@@ -4960,7 +4960,7 @@
         </p:nvSpPr>
         <p:spPr>
           <a:xfrm>
-            <a:off x="3615837" y="720000"/>
+            <a:off x="3271461" y="720000"/>
             <a:ext cx="1440000" cy="2160000"/>
           </a:xfrm>
           <a:prstGeom prst="rect">
@@ -5017,7 +5017,7 @@
         </p:nvSpPr>
         <p:spPr>
           <a:xfrm>
-            <a:off x="6747389" y="720000"/>
+            <a:off x="6403013" y="720000"/>
             <a:ext cx="2580227" cy="2160000"/>
           </a:xfrm>
           <a:prstGeom prst="rect">
@@ -5066,7 +5066,7 @@
         </p:nvSpPr>
         <p:spPr>
           <a:xfrm>
-            <a:off x="10425834" y="3270189"/>
+            <a:off x="10081458" y="3270189"/>
             <a:ext cx="1766165" cy="3335612"/>
           </a:xfrm>
           <a:prstGeom prst="rect">
@@ -5113,7 +5113,7 @@
         </p:nvSpPr>
         <p:spPr>
           <a:xfrm>
-            <a:off x="10421496" y="249382"/>
+            <a:off x="10077120" y="249382"/>
             <a:ext cx="1770504" cy="2945485"/>
           </a:xfrm>
           <a:prstGeom prst="rect">
@@ -5160,7 +5160,7 @@
         </p:nvSpPr>
         <p:spPr>
           <a:xfrm>
-            <a:off x="10490961" y="720000"/>
+            <a:off x="10146585" y="720000"/>
             <a:ext cx="1440000" cy="2160000"/>
           </a:xfrm>
           <a:prstGeom prst="rect">
@@ -5223,7 +5223,7 @@
         </p:nvSpPr>
         <p:spPr>
           <a:xfrm>
-            <a:off x="10469462" y="3722791"/>
+            <a:off x="10125086" y="3722791"/>
             <a:ext cx="1500258" cy="2138082"/>
           </a:xfrm>
           <a:prstGeom prst="rect">
@@ -5276,7 +5276,7 @@
         </p:nvCxnSpPr>
         <p:spPr>
           <a:xfrm flipH="1" flipV="1">
-            <a:off x="11210961" y="2880000"/>
+            <a:off x="10866585" y="2880000"/>
             <a:ext cx="8630" cy="842791"/>
           </a:xfrm>
           <a:prstGeom prst="straightConnector1">
@@ -5315,7 +5315,7 @@
         </p:nvSpPr>
         <p:spPr>
           <a:xfrm>
-            <a:off x="10634792" y="2896508"/>
+            <a:off x="10290416" y="2896508"/>
             <a:ext cx="1270245" cy="646331"/>
           </a:xfrm>
           <a:prstGeom prst="rect">
@@ -5350,7 +5350,7 @@
         </p:nvSpPr>
         <p:spPr>
           <a:xfrm>
-            <a:off x="9240884" y="1881756"/>
+            <a:off x="8908383" y="1881756"/>
             <a:ext cx="1401262" cy="923330"/>
           </a:xfrm>
           <a:prstGeom prst="rect">
@@ -5394,7 +5394,7 @@
         </p:nvCxnSpPr>
         <p:spPr>
           <a:xfrm flipH="1">
-            <a:off x="9310991" y="1800000"/>
+            <a:off x="8966615" y="1800000"/>
             <a:ext cx="1179970" cy="0"/>
           </a:xfrm>
           <a:prstGeom prst="straightConnector1">
@@ -5433,7 +5433,7 @@
         </p:nvSpPr>
         <p:spPr>
           <a:xfrm>
-            <a:off x="715800" y="249384"/>
+            <a:off x="371424" y="249384"/>
             <a:ext cx="1279256" cy="369332"/>
           </a:xfrm>
           <a:prstGeom prst="rect">
@@ -5469,7 +5469,7 @@
         </p:nvSpPr>
         <p:spPr>
           <a:xfrm>
-            <a:off x="722141" y="6237317"/>
+            <a:off x="377765" y="6237317"/>
             <a:ext cx="407611" cy="369332"/>
           </a:xfrm>
           <a:prstGeom prst="rect">
@@ -5505,7 +5505,7 @@
         </p:nvSpPr>
         <p:spPr>
           <a:xfrm>
-            <a:off x="10433855" y="252199"/>
+            <a:off x="10089479" y="252199"/>
             <a:ext cx="1902232" cy="369332"/>
           </a:xfrm>
           <a:prstGeom prst="rect">
@@ -5541,7 +5541,7 @@
         </p:nvSpPr>
         <p:spPr>
           <a:xfrm>
-            <a:off x="10442557" y="6223701"/>
+            <a:off x="10098181" y="6223701"/>
             <a:ext cx="1299250" cy="369332"/>
           </a:xfrm>
           <a:prstGeom prst="rect">

</xml_diff>